<commit_message>
Adding quizzes to slides.
</commit_message>
<xml_diff>
--- a/Day 1 Part 4/D1P4.pptx
+++ b/Day 1 Part 4/D1P4.pptx
@@ -225,7 +225,7 @@
 <file path=ppt/revisionInfo.xml><?xml version="1.0" encoding="utf-8"?>
 <p1510:revInfo xmlns:a="http://schemas.openxmlformats.org/drawingml/2006/main" xmlns:r="http://schemas.openxmlformats.org/officeDocument/2006/relationships" xmlns:p1510="http://schemas.microsoft.com/office/powerpoint/2015/10/main">
   <p1510:revLst>
-    <p1510:client id="{DB227F22-6C46-4C06-9514-CE8BFCB497BC}" v="35" dt="2026-01-12T06:24:34.196"/>
+    <p1510:client id="{025DD110-30CA-4067-8C76-9496598654AE}" v="2" dt="2026-03-17T10:32:51.315"/>
   </p1510:revLst>
 </p1510:revInfo>
 </file>
@@ -235,297 +235,18 @@
   <pc:docChgLst>
     <pc:chgData name="Matthieu De Mari" userId="dfb708c9-d8dc-439f-9a3b-c772bf4a311c" providerId="ADAL" clId="{81E9B007-0C2C-493E-9B93-55A62C9C1F12}"/>
     <pc:docChg chg="undo custSel addSld delSld modSld sldOrd addSection delSection modSection">
-      <pc:chgData name="Matthieu De Mari" userId="dfb708c9-d8dc-439f-9a3b-c772bf4a311c" providerId="ADAL" clId="{81E9B007-0C2C-493E-9B93-55A62C9C1F12}" dt="2026-01-12T06:24:51.128" v="1023" actId="20577"/>
+      <pc:chgData name="Matthieu De Mari" userId="dfb708c9-d8dc-439f-9a3b-c772bf4a311c" providerId="ADAL" clId="{81E9B007-0C2C-493E-9B93-55A62C9C1F12}" dt="2026-03-18T05:39:20.455" v="1208" actId="20577"/>
       <pc:docMkLst>
         <pc:docMk/>
       </pc:docMkLst>
-      <pc:sldChg chg="modSp mod">
-        <pc:chgData name="Matthieu De Mari" userId="dfb708c9-d8dc-439f-9a3b-c772bf4a311c" providerId="ADAL" clId="{81E9B007-0C2C-493E-9B93-55A62C9C1F12}" dt="2026-01-09T02:13:53.769" v="787" actId="20577"/>
-        <pc:sldMkLst>
-          <pc:docMk/>
-          <pc:sldMk cId="1036081419" sldId="346"/>
-        </pc:sldMkLst>
-        <pc:spChg chg="mod">
-          <ac:chgData name="Matthieu De Mari" userId="dfb708c9-d8dc-439f-9a3b-c772bf4a311c" providerId="ADAL" clId="{81E9B007-0C2C-493E-9B93-55A62C9C1F12}" dt="2026-01-09T02:13:53.769" v="787" actId="20577"/>
-          <ac:spMkLst>
-            <pc:docMk/>
-            <pc:sldMk cId="1036081419" sldId="346"/>
-            <ac:spMk id="2" creationId="{11A08BA8-9DEC-4471-8590-434E8D8BB4A0}"/>
-          </ac:spMkLst>
-        </pc:spChg>
-      </pc:sldChg>
-      <pc:sldChg chg="modSp mod">
-        <pc:chgData name="Matthieu De Mari" userId="dfb708c9-d8dc-439f-9a3b-c772bf4a311c" providerId="ADAL" clId="{81E9B007-0C2C-493E-9B93-55A62C9C1F12}" dt="2026-01-09T02:06:02.330" v="656" actId="20577"/>
-        <pc:sldMkLst>
-          <pc:docMk/>
-          <pc:sldMk cId="1040156172" sldId="377"/>
-        </pc:sldMkLst>
-        <pc:spChg chg="mod">
-          <ac:chgData name="Matthieu De Mari" userId="dfb708c9-d8dc-439f-9a3b-c772bf4a311c" providerId="ADAL" clId="{81E9B007-0C2C-493E-9B93-55A62C9C1F12}" dt="2026-01-09T02:06:02.330" v="656" actId="20577"/>
-          <ac:spMkLst>
-            <pc:docMk/>
-            <pc:sldMk cId="1040156172" sldId="377"/>
-            <ac:spMk id="2" creationId="{080CEB46-CC16-4D19-8C2C-AEE9471D8168}"/>
-          </ac:spMkLst>
-        </pc:spChg>
-      </pc:sldChg>
-      <pc:sldChg chg="modSp mod">
-        <pc:chgData name="Matthieu De Mari" userId="dfb708c9-d8dc-439f-9a3b-c772bf4a311c" providerId="ADAL" clId="{81E9B007-0C2C-493E-9B93-55A62C9C1F12}" dt="2026-01-09T02:06:42.363" v="698" actId="115"/>
-        <pc:sldMkLst>
-          <pc:docMk/>
-          <pc:sldMk cId="1464669599" sldId="517"/>
-        </pc:sldMkLst>
-        <pc:spChg chg="mod">
-          <ac:chgData name="Matthieu De Mari" userId="dfb708c9-d8dc-439f-9a3b-c772bf4a311c" providerId="ADAL" clId="{81E9B007-0C2C-493E-9B93-55A62C9C1F12}" dt="2026-01-09T01:53:32.373" v="468" actId="20577"/>
-          <ac:spMkLst>
-            <pc:docMk/>
-            <pc:sldMk cId="1464669599" sldId="517"/>
-            <ac:spMk id="2" creationId="{49D40417-A4D3-4CE8-96E7-708E2439AE7B}"/>
-          </ac:spMkLst>
-        </pc:spChg>
-        <pc:spChg chg="mod">
-          <ac:chgData name="Matthieu De Mari" userId="dfb708c9-d8dc-439f-9a3b-c772bf4a311c" providerId="ADAL" clId="{81E9B007-0C2C-493E-9B93-55A62C9C1F12}" dt="2026-01-09T02:06:42.363" v="698" actId="115"/>
-          <ac:spMkLst>
-            <pc:docMk/>
-            <pc:sldMk cId="1464669599" sldId="517"/>
-            <ac:spMk id="3" creationId="{35995840-A9D9-479A-A34F-EA7DC229D38E}"/>
-          </ac:spMkLst>
-        </pc:spChg>
-      </pc:sldChg>
-      <pc:sldChg chg="modSp add mod">
-        <pc:chgData name="Matthieu De Mari" userId="dfb708c9-d8dc-439f-9a3b-c772bf4a311c" providerId="ADAL" clId="{81E9B007-0C2C-493E-9B93-55A62C9C1F12}" dt="2026-01-12T06:24:51.128" v="1023" actId="20577"/>
-        <pc:sldMkLst>
-          <pc:docMk/>
-          <pc:sldMk cId="4272836236" sldId="548"/>
-        </pc:sldMkLst>
-        <pc:spChg chg="mod">
-          <ac:chgData name="Matthieu De Mari" userId="dfb708c9-d8dc-439f-9a3b-c772bf4a311c" providerId="ADAL" clId="{81E9B007-0C2C-493E-9B93-55A62C9C1F12}" dt="2026-01-12T06:24:45.182" v="1001" actId="20577"/>
-          <ac:spMkLst>
-            <pc:docMk/>
-            <pc:sldMk cId="4272836236" sldId="548"/>
-            <ac:spMk id="4" creationId="{33EBB267-24B9-144C-E4DE-C6D6CD35E719}"/>
-          </ac:spMkLst>
-        </pc:spChg>
-        <pc:spChg chg="mod">
-          <ac:chgData name="Matthieu De Mari" userId="dfb708c9-d8dc-439f-9a3b-c772bf4a311c" providerId="ADAL" clId="{81E9B007-0C2C-493E-9B93-55A62C9C1F12}" dt="2026-01-12T06:24:51.128" v="1023" actId="20577"/>
-          <ac:spMkLst>
-            <pc:docMk/>
-            <pc:sldMk cId="4272836236" sldId="548"/>
-            <ac:spMk id="5" creationId="{8784BD3C-A362-227F-DB67-10CF1E267B66}"/>
-          </ac:spMkLst>
-        </pc:spChg>
-      </pc:sldChg>
-      <pc:sldChg chg="modSp mod">
-        <pc:chgData name="Matthieu De Mari" userId="dfb708c9-d8dc-439f-9a3b-c772bf4a311c" providerId="ADAL" clId="{81E9B007-0C2C-493E-9B93-55A62C9C1F12}" dt="2026-01-09T02:07:10.692" v="705" actId="115"/>
-        <pc:sldMkLst>
-          <pc:docMk/>
-          <pc:sldMk cId="209871370" sldId="568"/>
-        </pc:sldMkLst>
-        <pc:spChg chg="mod">
-          <ac:chgData name="Matthieu De Mari" userId="dfb708c9-d8dc-439f-9a3b-c772bf4a311c" providerId="ADAL" clId="{81E9B007-0C2C-493E-9B93-55A62C9C1F12}" dt="2026-01-09T02:07:10.692" v="705" actId="115"/>
-          <ac:spMkLst>
-            <pc:docMk/>
-            <pc:sldMk cId="209871370" sldId="568"/>
-            <ac:spMk id="3" creationId="{5AA41464-B2B5-4EE7-DEF2-910D29FE3DA2}"/>
-          </ac:spMkLst>
-        </pc:spChg>
-      </pc:sldChg>
-      <pc:sldChg chg="modSp mod">
-        <pc:chgData name="Matthieu De Mari" userId="dfb708c9-d8dc-439f-9a3b-c772bf4a311c" providerId="ADAL" clId="{81E9B007-0C2C-493E-9B93-55A62C9C1F12}" dt="2025-12-18T21:50:16.109" v="445" actId="20577"/>
-        <pc:sldMkLst>
-          <pc:docMk/>
-          <pc:sldMk cId="548617228" sldId="570"/>
-        </pc:sldMkLst>
-        <pc:spChg chg="mod">
-          <ac:chgData name="Matthieu De Mari" userId="dfb708c9-d8dc-439f-9a3b-c772bf4a311c" providerId="ADAL" clId="{81E9B007-0C2C-493E-9B93-55A62C9C1F12}" dt="2025-12-18T21:50:16.109" v="445" actId="20577"/>
-          <ac:spMkLst>
-            <pc:docMk/>
-            <pc:sldMk cId="548617228" sldId="570"/>
-            <ac:spMk id="3" creationId="{E475B357-0886-EDDA-5F55-77F580FB4D9B}"/>
-          </ac:spMkLst>
-        </pc:spChg>
-      </pc:sldChg>
-      <pc:sldChg chg="modSp mod">
-        <pc:chgData name="Matthieu De Mari" userId="dfb708c9-d8dc-439f-9a3b-c772bf4a311c" providerId="ADAL" clId="{81E9B007-0C2C-493E-9B93-55A62C9C1F12}" dt="2026-01-09T02:09:56.499" v="725" actId="27636"/>
-        <pc:sldMkLst>
-          <pc:docMk/>
-          <pc:sldMk cId="757709305" sldId="572"/>
-        </pc:sldMkLst>
-        <pc:spChg chg="mod">
-          <ac:chgData name="Matthieu De Mari" userId="dfb708c9-d8dc-439f-9a3b-c772bf4a311c" providerId="ADAL" clId="{81E9B007-0C2C-493E-9B93-55A62C9C1F12}" dt="2026-01-09T02:09:56.499" v="725" actId="27636"/>
-          <ac:spMkLst>
-            <pc:docMk/>
-            <pc:sldMk cId="757709305" sldId="572"/>
-            <ac:spMk id="3" creationId="{5AA41464-B2B5-4EE7-DEF2-910D29FE3DA2}"/>
-          </ac:spMkLst>
-        </pc:spChg>
-      </pc:sldChg>
-      <pc:sldChg chg="modSp">
-        <pc:chgData name="Matthieu De Mari" userId="dfb708c9-d8dc-439f-9a3b-c772bf4a311c" providerId="ADAL" clId="{81E9B007-0C2C-493E-9B93-55A62C9C1F12}" dt="2026-01-09T02:10:18.927" v="735" actId="20577"/>
-        <pc:sldMkLst>
-          <pc:docMk/>
-          <pc:sldMk cId="3960741178" sldId="573"/>
-        </pc:sldMkLst>
-        <pc:spChg chg="mod">
-          <ac:chgData name="Matthieu De Mari" userId="dfb708c9-d8dc-439f-9a3b-c772bf4a311c" providerId="ADAL" clId="{81E9B007-0C2C-493E-9B93-55A62C9C1F12}" dt="2026-01-09T02:10:18.927" v="735" actId="20577"/>
-          <ac:spMkLst>
-            <pc:docMk/>
-            <pc:sldMk cId="3960741178" sldId="573"/>
-            <ac:spMk id="3" creationId="{5AA41464-B2B5-4EE7-DEF2-910D29FE3DA2}"/>
-          </ac:spMkLst>
-        </pc:spChg>
-      </pc:sldChg>
-      <pc:sldChg chg="modSp mod">
-        <pc:chgData name="Matthieu De Mari" userId="dfb708c9-d8dc-439f-9a3b-c772bf4a311c" providerId="ADAL" clId="{81E9B007-0C2C-493E-9B93-55A62C9C1F12}" dt="2026-01-09T02:11:36.521" v="747" actId="20577"/>
-        <pc:sldMkLst>
-          <pc:docMk/>
-          <pc:sldMk cId="1620224169" sldId="577"/>
-        </pc:sldMkLst>
-        <pc:spChg chg="mod">
-          <ac:chgData name="Matthieu De Mari" userId="dfb708c9-d8dc-439f-9a3b-c772bf4a311c" providerId="ADAL" clId="{81E9B007-0C2C-493E-9B93-55A62C9C1F12}" dt="2026-01-09T02:11:36.521" v="747" actId="20577"/>
-          <ac:spMkLst>
-            <pc:docMk/>
-            <pc:sldMk cId="1620224169" sldId="577"/>
-            <ac:spMk id="8" creationId="{56F73953-A2CE-A62E-D071-2A65983D9173}"/>
-          </ac:spMkLst>
-        </pc:spChg>
-      </pc:sldChg>
-      <pc:sldChg chg="modSp">
-        <pc:chgData name="Matthieu De Mari" userId="dfb708c9-d8dc-439f-9a3b-c772bf4a311c" providerId="ADAL" clId="{81E9B007-0C2C-493E-9B93-55A62C9C1F12}" dt="2026-01-08T10:27:18.262" v="446" actId="20577"/>
-        <pc:sldMkLst>
-          <pc:docMk/>
-          <pc:sldMk cId="174187107" sldId="578"/>
-        </pc:sldMkLst>
-        <pc:spChg chg="mod">
-          <ac:chgData name="Matthieu De Mari" userId="dfb708c9-d8dc-439f-9a3b-c772bf4a311c" providerId="ADAL" clId="{81E9B007-0C2C-493E-9B93-55A62C9C1F12}" dt="2026-01-08T10:27:18.262" v="446" actId="20577"/>
-          <ac:spMkLst>
-            <pc:docMk/>
-            <pc:sldMk cId="174187107" sldId="578"/>
-            <ac:spMk id="16" creationId="{5CF0157F-6568-59C9-9C76-67042E94E139}"/>
-          </ac:spMkLst>
-        </pc:spChg>
-      </pc:sldChg>
-      <pc:sldChg chg="modSp mod">
-        <pc:chgData name="Matthieu De Mari" userId="dfb708c9-d8dc-439f-9a3b-c772bf4a311c" providerId="ADAL" clId="{81E9B007-0C2C-493E-9B93-55A62C9C1F12}" dt="2026-01-09T02:12:02.891" v="749" actId="14100"/>
-        <pc:sldMkLst>
-          <pc:docMk/>
-          <pc:sldMk cId="3045576156" sldId="579"/>
-        </pc:sldMkLst>
-        <pc:spChg chg="mod">
-          <ac:chgData name="Matthieu De Mari" userId="dfb708c9-d8dc-439f-9a3b-c772bf4a311c" providerId="ADAL" clId="{81E9B007-0C2C-493E-9B93-55A62C9C1F12}" dt="2026-01-09T02:12:02.891" v="749" actId="14100"/>
-          <ac:spMkLst>
-            <pc:docMk/>
-            <pc:sldMk cId="3045576156" sldId="579"/>
-            <ac:spMk id="3" creationId="{DAC23481-5FCE-ADF6-1072-441B81A61296}"/>
-          </ac:spMkLst>
-        </pc:spChg>
-      </pc:sldChg>
-      <pc:sldChg chg="modSp mod">
-        <pc:chgData name="Matthieu De Mari" userId="dfb708c9-d8dc-439f-9a3b-c772bf4a311c" providerId="ADAL" clId="{81E9B007-0C2C-493E-9B93-55A62C9C1F12}" dt="2026-01-09T02:12:41.155" v="781" actId="20577"/>
-        <pc:sldMkLst>
-          <pc:docMk/>
-          <pc:sldMk cId="4030169117" sldId="580"/>
-        </pc:sldMkLst>
-        <pc:spChg chg="mod">
-          <ac:chgData name="Matthieu De Mari" userId="dfb708c9-d8dc-439f-9a3b-c772bf4a311c" providerId="ADAL" clId="{81E9B007-0C2C-493E-9B93-55A62C9C1F12}" dt="2026-01-09T02:12:41.155" v="781" actId="20577"/>
-          <ac:spMkLst>
-            <pc:docMk/>
-            <pc:sldMk cId="4030169117" sldId="580"/>
-            <ac:spMk id="8" creationId="{56F73953-A2CE-A62E-D071-2A65983D9173}"/>
-          </ac:spMkLst>
-        </pc:spChg>
-      </pc:sldChg>
-      <pc:sldChg chg="modSp mod">
-        <pc:chgData name="Matthieu De Mari" userId="dfb708c9-d8dc-439f-9a3b-c772bf4a311c" providerId="ADAL" clId="{81E9B007-0C2C-493E-9B93-55A62C9C1F12}" dt="2025-12-18T21:46:10.439" v="402" actId="20577"/>
-        <pc:sldMkLst>
-          <pc:docMk/>
-          <pc:sldMk cId="1162878205" sldId="582"/>
-        </pc:sldMkLst>
-        <pc:spChg chg="mod">
-          <ac:chgData name="Matthieu De Mari" userId="dfb708c9-d8dc-439f-9a3b-c772bf4a311c" providerId="ADAL" clId="{81E9B007-0C2C-493E-9B93-55A62C9C1F12}" dt="2025-12-18T21:46:10.439" v="402" actId="20577"/>
-          <ac:spMkLst>
-            <pc:docMk/>
-            <pc:sldMk cId="1162878205" sldId="582"/>
-            <ac:spMk id="4" creationId="{720BC5D3-5690-1CC7-4476-5F4D434E7343}"/>
-          </ac:spMkLst>
-        </pc:spChg>
-      </pc:sldChg>
-      <pc:sldChg chg="modSp mod">
-        <pc:chgData name="Matthieu De Mari" userId="dfb708c9-d8dc-439f-9a3b-c772bf4a311c" providerId="ADAL" clId="{81E9B007-0C2C-493E-9B93-55A62C9C1F12}" dt="2026-01-09T02:13:50.282" v="784" actId="20577"/>
-        <pc:sldMkLst>
-          <pc:docMk/>
-          <pc:sldMk cId="4234745274" sldId="584"/>
-        </pc:sldMkLst>
-        <pc:spChg chg="mod">
-          <ac:chgData name="Matthieu De Mari" userId="dfb708c9-d8dc-439f-9a3b-c772bf4a311c" providerId="ADAL" clId="{81E9B007-0C2C-493E-9B93-55A62C9C1F12}" dt="2026-01-09T02:13:50.282" v="784" actId="20577"/>
-          <ac:spMkLst>
-            <pc:docMk/>
-            <pc:sldMk cId="4234745274" sldId="584"/>
-            <ac:spMk id="2" creationId="{11A08BA8-9DEC-4471-8590-434E8D8BB4A0}"/>
-          </ac:spMkLst>
-        </pc:spChg>
-      </pc:sldChg>
-      <pc:sldChg chg="modSp mod">
-        <pc:chgData name="Matthieu De Mari" userId="dfb708c9-d8dc-439f-9a3b-c772bf4a311c" providerId="ADAL" clId="{81E9B007-0C2C-493E-9B93-55A62C9C1F12}" dt="2026-01-09T02:07:47.617" v="706" actId="115"/>
-        <pc:sldMkLst>
-          <pc:docMk/>
-          <pc:sldMk cId="3605419039" sldId="586"/>
-        </pc:sldMkLst>
-        <pc:spChg chg="mod">
-          <ac:chgData name="Matthieu De Mari" userId="dfb708c9-d8dc-439f-9a3b-c772bf4a311c" providerId="ADAL" clId="{81E9B007-0C2C-493E-9B93-55A62C9C1F12}" dt="2026-01-09T02:07:47.617" v="706" actId="115"/>
-          <ac:spMkLst>
-            <pc:docMk/>
-            <pc:sldMk cId="3605419039" sldId="586"/>
-            <ac:spMk id="7" creationId="{3EFEA9E2-AE7C-23F8-DA29-FB5939F4F74C}"/>
-          </ac:spMkLst>
-        </pc:spChg>
-      </pc:sldChg>
-      <pc:sldChg chg="modSp">
-        <pc:chgData name="Matthieu De Mari" userId="dfb708c9-d8dc-439f-9a3b-c772bf4a311c" providerId="ADAL" clId="{81E9B007-0C2C-493E-9B93-55A62C9C1F12}" dt="2026-01-09T02:10:07.056" v="726"/>
-        <pc:sldMkLst>
-          <pc:docMk/>
-          <pc:sldMk cId="884021004" sldId="587"/>
-        </pc:sldMkLst>
-        <pc:spChg chg="mod">
-          <ac:chgData name="Matthieu De Mari" userId="dfb708c9-d8dc-439f-9a3b-c772bf4a311c" providerId="ADAL" clId="{81E9B007-0C2C-493E-9B93-55A62C9C1F12}" dt="2026-01-09T02:10:07.056" v="726"/>
-          <ac:spMkLst>
-            <pc:docMk/>
-            <pc:sldMk cId="884021004" sldId="587"/>
-            <ac:spMk id="3" creationId="{5AA41464-B2B5-4EE7-DEF2-910D29FE3DA2}"/>
-          </ac:spMkLst>
-        </pc:spChg>
-      </pc:sldChg>
-      <pc:sldChg chg="modSp mod">
-        <pc:chgData name="Matthieu De Mari" userId="dfb708c9-d8dc-439f-9a3b-c772bf4a311c" providerId="ADAL" clId="{81E9B007-0C2C-493E-9B93-55A62C9C1F12}" dt="2026-01-09T02:09:17.486" v="710" actId="14100"/>
-        <pc:sldMkLst>
-          <pc:docMk/>
-          <pc:sldMk cId="2267076689" sldId="588"/>
-        </pc:sldMkLst>
-        <pc:spChg chg="mod">
-          <ac:chgData name="Matthieu De Mari" userId="dfb708c9-d8dc-439f-9a3b-c772bf4a311c" providerId="ADAL" clId="{81E9B007-0C2C-493E-9B93-55A62C9C1F12}" dt="2026-01-09T02:09:17.486" v="710" actId="14100"/>
-          <ac:spMkLst>
-            <pc:docMk/>
-            <pc:sldMk cId="2267076689" sldId="588"/>
-            <ac:spMk id="6" creationId="{67AEAB6F-9509-B275-EBFE-87BAAB433D7F}"/>
-          </ac:spMkLst>
-        </pc:spChg>
-        <pc:spChg chg="mod">
-          <ac:chgData name="Matthieu De Mari" userId="dfb708c9-d8dc-439f-9a3b-c772bf4a311c" providerId="ADAL" clId="{81E9B007-0C2C-493E-9B93-55A62C9C1F12}" dt="2026-01-09T02:09:15.517" v="709" actId="14100"/>
-          <ac:spMkLst>
-            <pc:docMk/>
-            <pc:sldMk cId="2267076689" sldId="588"/>
-            <ac:spMk id="7" creationId="{A529F1D0-FF7B-BBB6-460B-7825B57FED7C}"/>
-          </ac:spMkLst>
-        </pc:spChg>
-      </pc:sldChg>
       <pc:sldChg chg="addSp delSp modSp new mod modClrScheme chgLayout">
-        <pc:chgData name="Matthieu De Mari" userId="dfb708c9-d8dc-439f-9a3b-c772bf4a311c" providerId="ADAL" clId="{81E9B007-0C2C-493E-9B93-55A62C9C1F12}" dt="2026-01-09T02:15:39.822" v="964" actId="20577"/>
+        <pc:chgData name="Matthieu De Mari" userId="dfb708c9-d8dc-439f-9a3b-c772bf4a311c" providerId="ADAL" clId="{81E9B007-0C2C-493E-9B93-55A62C9C1F12}" dt="2026-03-18T05:39:20.455" v="1208" actId="20577"/>
         <pc:sldMkLst>
           <pc:docMk/>
           <pc:sldMk cId="2100063369" sldId="598"/>
         </pc:sldMkLst>
         <pc:spChg chg="mod ord">
-          <ac:chgData name="Matthieu De Mari" userId="dfb708c9-d8dc-439f-9a3b-c772bf4a311c" providerId="ADAL" clId="{81E9B007-0C2C-493E-9B93-55A62C9C1F12}" dt="2026-01-09T02:15:30.381" v="960" actId="700"/>
+          <ac:chgData name="Matthieu De Mari" userId="dfb708c9-d8dc-439f-9a3b-c772bf4a311c" providerId="ADAL" clId="{81E9B007-0C2C-493E-9B93-55A62C9C1F12}" dt="2026-03-17T10:32:55.565" v="1029" actId="700"/>
           <ac:spMkLst>
             <pc:docMk/>
             <pc:sldMk cId="2100063369" sldId="598"/>
@@ -533,7 +254,7 @@
           </ac:spMkLst>
         </pc:spChg>
         <pc:spChg chg="mod ord">
-          <ac:chgData name="Matthieu De Mari" userId="dfb708c9-d8dc-439f-9a3b-c772bf4a311c" providerId="ADAL" clId="{81E9B007-0C2C-493E-9B93-55A62C9C1F12}" dt="2026-01-09T02:15:39.822" v="964" actId="20577"/>
+          <ac:chgData name="Matthieu De Mari" userId="dfb708c9-d8dc-439f-9a3b-c772bf4a311c" providerId="ADAL" clId="{81E9B007-0C2C-493E-9B93-55A62C9C1F12}" dt="2026-03-18T05:39:20.455" v="1208" actId="20577"/>
           <ac:spMkLst>
             <pc:docMk/>
             <pc:sldMk cId="2100063369" sldId="598"/>
@@ -5856,7 +5577,7 @@
           <a:p>
             <a:fld id="{61478373-EB31-4867-8CF0-FA31364748A5}" type="datetimeFigureOut">
               <a:rPr lang="en-GB" smtClean="0"/>
-              <a:t>12/01/2026</a:t>
+              <a:t>18/03/2026</a:t>
             </a:fld>
             <a:endParaRPr lang="en-GB"/>
           </a:p>
@@ -6273,7 +5994,7 @@
           <a:p>
             <a:fld id="{E85DF616-B21E-4EF6-A6A5-95E2FB3EB1A1}" type="datetimeFigureOut">
               <a:rPr lang="en-GB" smtClean="0"/>
-              <a:t>12/01/2026</a:t>
+              <a:t>18/03/2026</a:t>
             </a:fld>
             <a:endParaRPr lang="en-GB"/>
           </a:p>
@@ -6473,7 +6194,7 @@
           <a:p>
             <a:fld id="{E85DF616-B21E-4EF6-A6A5-95E2FB3EB1A1}" type="datetimeFigureOut">
               <a:rPr lang="en-GB" smtClean="0"/>
-              <a:t>12/01/2026</a:t>
+              <a:t>18/03/2026</a:t>
             </a:fld>
             <a:endParaRPr lang="en-GB"/>
           </a:p>
@@ -6683,7 +6404,7 @@
           <a:p>
             <a:fld id="{E85DF616-B21E-4EF6-A6A5-95E2FB3EB1A1}" type="datetimeFigureOut">
               <a:rPr lang="en-GB" smtClean="0"/>
-              <a:t>12/01/2026</a:t>
+              <a:t>18/03/2026</a:t>
             </a:fld>
             <a:endParaRPr lang="en-GB"/>
           </a:p>
@@ -6883,7 +6604,7 @@
           <a:p>
             <a:fld id="{E85DF616-B21E-4EF6-A6A5-95E2FB3EB1A1}" type="datetimeFigureOut">
               <a:rPr lang="en-GB" smtClean="0"/>
-              <a:t>12/01/2026</a:t>
+              <a:t>18/03/2026</a:t>
             </a:fld>
             <a:endParaRPr lang="en-GB"/>
           </a:p>
@@ -7159,7 +6880,7 @@
           <a:p>
             <a:fld id="{E85DF616-B21E-4EF6-A6A5-95E2FB3EB1A1}" type="datetimeFigureOut">
               <a:rPr lang="en-GB" smtClean="0"/>
-              <a:t>12/01/2026</a:t>
+              <a:t>18/03/2026</a:t>
             </a:fld>
             <a:endParaRPr lang="en-GB"/>
           </a:p>
@@ -7427,7 +7148,7 @@
           <a:p>
             <a:fld id="{E85DF616-B21E-4EF6-A6A5-95E2FB3EB1A1}" type="datetimeFigureOut">
               <a:rPr lang="en-GB" smtClean="0"/>
-              <a:t>12/01/2026</a:t>
+              <a:t>18/03/2026</a:t>
             </a:fld>
             <a:endParaRPr lang="en-GB"/>
           </a:p>
@@ -7842,7 +7563,7 @@
           <a:p>
             <a:fld id="{E85DF616-B21E-4EF6-A6A5-95E2FB3EB1A1}" type="datetimeFigureOut">
               <a:rPr lang="en-GB" smtClean="0"/>
-              <a:t>12/01/2026</a:t>
+              <a:t>18/03/2026</a:t>
             </a:fld>
             <a:endParaRPr lang="en-GB"/>
           </a:p>
@@ -7984,7 +7705,7 @@
           <a:p>
             <a:fld id="{E85DF616-B21E-4EF6-A6A5-95E2FB3EB1A1}" type="datetimeFigureOut">
               <a:rPr lang="en-GB" smtClean="0"/>
-              <a:t>12/01/2026</a:t>
+              <a:t>18/03/2026</a:t>
             </a:fld>
             <a:endParaRPr lang="en-GB"/>
           </a:p>
@@ -8097,7 +7818,7 @@
           <a:p>
             <a:fld id="{E85DF616-B21E-4EF6-A6A5-95E2FB3EB1A1}" type="datetimeFigureOut">
               <a:rPr lang="en-GB" smtClean="0"/>
-              <a:t>12/01/2026</a:t>
+              <a:t>18/03/2026</a:t>
             </a:fld>
             <a:endParaRPr lang="en-GB"/>
           </a:p>
@@ -8410,7 +8131,7 @@
           <a:p>
             <a:fld id="{E85DF616-B21E-4EF6-A6A5-95E2FB3EB1A1}" type="datetimeFigureOut">
               <a:rPr lang="en-GB" smtClean="0"/>
-              <a:t>12/01/2026</a:t>
+              <a:t>18/03/2026</a:t>
             </a:fld>
             <a:endParaRPr lang="en-GB"/>
           </a:p>
@@ -8699,7 +8420,7 @@
           <a:p>
             <a:fld id="{E85DF616-B21E-4EF6-A6A5-95E2FB3EB1A1}" type="datetimeFigureOut">
               <a:rPr lang="en-GB" smtClean="0"/>
-              <a:t>12/01/2026</a:t>
+              <a:t>18/03/2026</a:t>
             </a:fld>
             <a:endParaRPr lang="en-GB"/>
           </a:p>
@@ -8942,7 +8663,7 @@
           <a:p>
             <a:fld id="{E85DF616-B21E-4EF6-A6A5-95E2FB3EB1A1}" type="datetimeFigureOut">
               <a:rPr lang="en-GB" smtClean="0"/>
-              <a:t>12/01/2026</a:t>
+              <a:t>18/03/2026</a:t>
             </a:fld>
             <a:endParaRPr lang="en-GB"/>
           </a:p>
@@ -17782,15 +17503,10 @@
             <a:spLocks noGrp="1"/>
           </p:cNvSpPr>
           <p:nvPr>
-            <p:ph sz="half" idx="1"/>
+            <p:ph idx="1"/>
           </p:nvPr>
         </p:nvSpPr>
-        <p:spPr>
-          <a:xfrm>
-            <a:off x="838200" y="1825624"/>
-            <a:ext cx="5181600" cy="5032375"/>
-          </a:xfrm>
-        </p:spPr>
+        <p:spPr/>
         <p:txBody>
           <a:bodyPr>
             <a:normAutofit/>
@@ -17803,28 +17519,23 @@
             </a:r>
           </a:p>
           <a:p>
-            <a:endParaRPr lang="en-GB" dirty="0"/>
-          </a:p>
-          <a:p>
-            <a:endParaRPr lang="en-GB" dirty="0"/>
-          </a:p>
-          <a:p>
-            <a:pPr marL="0" indent="0">
-              <a:buNone/>
-            </a:pPr>
-            <a:endParaRPr lang="en-GB" dirty="0"/>
-          </a:p>
-          <a:p>
-            <a:pPr marL="0" indent="0">
-              <a:buNone/>
-            </a:pPr>
-            <a:endParaRPr lang="en-GB"/>
-          </a:p>
-          <a:p>
-            <a:pPr marL="0" indent="0">
-              <a:buNone/>
-            </a:pPr>
-            <a:endParaRPr lang="en-GB" dirty="0"/>
+            <a:r>
+              <a:rPr lang="en-GB" dirty="0">
+                <a:hlinkClick r:id="rId2"/>
+              </a:rPr>
+              <a:t>https://docs.google.com/forms/d/e/1FAIpQLSfv491k7_oIji8HTwRyFME7S_nrPGQu8cBkfUTQ4wXdqDd0iA/viewform?usp=header</a:t>
+            </a:r>
+            <a:r>
+              <a:rPr lang="en-GB" dirty="0"/>
+              <a:t> </a:t>
+            </a:r>
+          </a:p>
+          <a:p>
+            <a:endParaRPr lang="en-GB" b="1" dirty="0">
+              <a:solidFill>
+                <a:srgbClr val="C00000"/>
+              </a:solidFill>
+            </a:endParaRPr>
           </a:p>
           <a:p>
             <a:r>
@@ -17833,7 +17544,33 @@
                   <a:srgbClr val="C00000"/>
                 </a:solidFill>
               </a:rPr>
-              <a:t>Deadline: XXXX</a:t>
+              <a:t>Deadline for submission: 22 March 2026, 11.59pm</a:t>
+            </a:r>
+          </a:p>
+          <a:p>
+            <a:r>
+              <a:rPr lang="en-GB" b="1" dirty="0">
+                <a:solidFill>
+                  <a:srgbClr val="C00000"/>
+                </a:solidFill>
+              </a:rPr>
+              <a:t>Note: Please ignore the score shown at the end of the quiz, after submission, as I have not yet fully implemented the </a:t>
+            </a:r>
+            <a:r>
+              <a:rPr lang="en-GB" b="1" dirty="0" err="1">
+                <a:solidFill>
+                  <a:srgbClr val="C00000"/>
+                </a:solidFill>
+              </a:rPr>
+              <a:t>autograder</a:t>
+            </a:r>
+            <a:r>
+              <a:rPr lang="en-GB" b="1" dirty="0">
+                <a:solidFill>
+                  <a:srgbClr val="C00000"/>
+                </a:solidFill>
+              </a:rPr>
+              <a:t>!</a:t>
             </a:r>
           </a:p>
         </p:txBody>

</xml_diff>

<commit_message>
Revisions to D1 and D2 materials.
</commit_message>
<xml_diff>
--- a/Day 1 Part 4/D1P4.pptx
+++ b/Day 1 Part 4/D1P4.pptx
@@ -225,7 +225,7 @@
 <file path=ppt/revisionInfo.xml><?xml version="1.0" encoding="utf-8"?>
 <p1510:revInfo xmlns:a="http://schemas.openxmlformats.org/drawingml/2006/main" xmlns:r="http://schemas.openxmlformats.org/officeDocument/2006/relationships" xmlns:p1510="http://schemas.microsoft.com/office/powerpoint/2015/10/main">
   <p1510:revLst>
-    <p1510:client id="{025DD110-30CA-4067-8C76-9496598654AE}" v="2" dt="2026-03-17T10:32:51.315"/>
+    <p1510:client id="{025DD110-30CA-4067-8C76-9496598654AE}" v="22" dt="2026-03-20T08:15:08.101"/>
   </p1510:revLst>
 </p1510:revInfo>
 </file>
@@ -235,10 +235,70 @@
   <pc:docChgLst>
     <pc:chgData name="Matthieu De Mari" userId="dfb708c9-d8dc-439f-9a3b-c772bf4a311c" providerId="ADAL" clId="{81E9B007-0C2C-493E-9B93-55A62C9C1F12}"/>
     <pc:docChg chg="undo custSel addSld delSld modSld sldOrd addSection delSection modSection">
-      <pc:chgData name="Matthieu De Mari" userId="dfb708c9-d8dc-439f-9a3b-c772bf4a311c" providerId="ADAL" clId="{81E9B007-0C2C-493E-9B93-55A62C9C1F12}" dt="2026-03-18T05:39:20.455" v="1208" actId="20577"/>
+      <pc:chgData name="Matthieu De Mari" userId="dfb708c9-d8dc-439f-9a3b-c772bf4a311c" providerId="ADAL" clId="{81E9B007-0C2C-493E-9B93-55A62C9C1F12}" dt="2026-03-20T08:22:43.290" v="1236" actId="20577"/>
       <pc:docMkLst>
         <pc:docMk/>
       </pc:docMkLst>
+      <pc:sldChg chg="modSp">
+        <pc:chgData name="Matthieu De Mari" userId="dfb708c9-d8dc-439f-9a3b-c772bf4a311c" providerId="ADAL" clId="{81E9B007-0C2C-493E-9B93-55A62C9C1F12}" dt="2026-03-20T07:39:08.577" v="1215" actId="20577"/>
+        <pc:sldMkLst>
+          <pc:docMk/>
+          <pc:sldMk cId="757709305" sldId="572"/>
+        </pc:sldMkLst>
+        <pc:spChg chg="mod">
+          <ac:chgData name="Matthieu De Mari" userId="dfb708c9-d8dc-439f-9a3b-c772bf4a311c" providerId="ADAL" clId="{81E9B007-0C2C-493E-9B93-55A62C9C1F12}" dt="2026-03-20T07:39:08.577" v="1215" actId="20577"/>
+          <ac:spMkLst>
+            <pc:docMk/>
+            <pc:sldMk cId="757709305" sldId="572"/>
+            <ac:spMk id="3" creationId="{5AA41464-B2B5-4EE7-DEF2-910D29FE3DA2}"/>
+          </ac:spMkLst>
+        </pc:spChg>
+      </pc:sldChg>
+      <pc:sldChg chg="modSp mod">
+        <pc:chgData name="Matthieu De Mari" userId="dfb708c9-d8dc-439f-9a3b-c772bf4a311c" providerId="ADAL" clId="{81E9B007-0C2C-493E-9B93-55A62C9C1F12}" dt="2026-03-20T08:22:43.290" v="1236" actId="20577"/>
+        <pc:sldMkLst>
+          <pc:docMk/>
+          <pc:sldMk cId="4234745274" sldId="584"/>
+        </pc:sldMkLst>
+        <pc:spChg chg="mod">
+          <ac:chgData name="Matthieu De Mari" userId="dfb708c9-d8dc-439f-9a3b-c772bf4a311c" providerId="ADAL" clId="{81E9B007-0C2C-493E-9B93-55A62C9C1F12}" dt="2026-03-20T08:22:43.290" v="1236" actId="20577"/>
+          <ac:spMkLst>
+            <pc:docMk/>
+            <pc:sldMk cId="4234745274" sldId="584"/>
+            <ac:spMk id="3" creationId="{47E3549C-D723-41E6-8478-270ACE043694}"/>
+          </ac:spMkLst>
+        </pc:spChg>
+      </pc:sldChg>
+      <pc:sldChg chg="modSp mod">
+        <pc:chgData name="Matthieu De Mari" userId="dfb708c9-d8dc-439f-9a3b-c772bf4a311c" providerId="ADAL" clId="{81E9B007-0C2C-493E-9B93-55A62C9C1F12}" dt="2026-03-20T08:15:08.409" v="1222" actId="27636"/>
+        <pc:sldMkLst>
+          <pc:docMk/>
+          <pc:sldMk cId="884021004" sldId="587"/>
+        </pc:sldMkLst>
+        <pc:spChg chg="mod">
+          <ac:chgData name="Matthieu De Mari" userId="dfb708c9-d8dc-439f-9a3b-c772bf4a311c" providerId="ADAL" clId="{81E9B007-0C2C-493E-9B93-55A62C9C1F12}" dt="2026-03-20T08:15:08.409" v="1222" actId="27636"/>
+          <ac:spMkLst>
+            <pc:docMk/>
+            <pc:sldMk cId="884021004" sldId="587"/>
+            <ac:spMk id="3" creationId="{5AA41464-B2B5-4EE7-DEF2-910D29FE3DA2}"/>
+          </ac:spMkLst>
+        </pc:spChg>
+      </pc:sldChg>
+      <pc:sldChg chg="modSp mod">
+        <pc:chgData name="Matthieu De Mari" userId="dfb708c9-d8dc-439f-9a3b-c772bf4a311c" providerId="ADAL" clId="{81E9B007-0C2C-493E-9B93-55A62C9C1F12}" dt="2026-03-20T08:22:34.845" v="1223" actId="20577"/>
+        <pc:sldMkLst>
+          <pc:docMk/>
+          <pc:sldMk cId="3219688854" sldId="597"/>
+        </pc:sldMkLst>
+        <pc:spChg chg="mod">
+          <ac:chgData name="Matthieu De Mari" userId="dfb708c9-d8dc-439f-9a3b-c772bf4a311c" providerId="ADAL" clId="{81E9B007-0C2C-493E-9B93-55A62C9C1F12}" dt="2026-03-20T08:22:34.845" v="1223" actId="20577"/>
+          <ac:spMkLst>
+            <pc:docMk/>
+            <pc:sldMk cId="3219688854" sldId="597"/>
+            <ac:spMk id="7" creationId="{A529F1D0-FF7B-BBB6-460B-7825B57FED7C}"/>
+          </ac:spMkLst>
+        </pc:spChg>
+      </pc:sldChg>
       <pc:sldChg chg="addSp delSp modSp new mod modClrScheme chgLayout">
         <pc:chgData name="Matthieu De Mari" userId="dfb708c9-d8dc-439f-9a3b-c772bf4a311c" providerId="ADAL" clId="{81E9B007-0C2C-493E-9B93-55A62C9C1F12}" dt="2026-03-18T05:39:20.455" v="1208" actId="20577"/>
         <pc:sldMkLst>
@@ -5577,7 +5637,7 @@
           <a:p>
             <a:fld id="{61478373-EB31-4867-8CF0-FA31364748A5}" type="datetimeFigureOut">
               <a:rPr lang="en-GB" smtClean="0"/>
-              <a:t>18/03/2026</a:t>
+              <a:t>20/03/2026</a:t>
             </a:fld>
             <a:endParaRPr lang="en-GB"/>
           </a:p>
@@ -5994,7 +6054,7 @@
           <a:p>
             <a:fld id="{E85DF616-B21E-4EF6-A6A5-95E2FB3EB1A1}" type="datetimeFigureOut">
               <a:rPr lang="en-GB" smtClean="0"/>
-              <a:t>18/03/2026</a:t>
+              <a:t>20/03/2026</a:t>
             </a:fld>
             <a:endParaRPr lang="en-GB"/>
           </a:p>
@@ -6194,7 +6254,7 @@
           <a:p>
             <a:fld id="{E85DF616-B21E-4EF6-A6A5-95E2FB3EB1A1}" type="datetimeFigureOut">
               <a:rPr lang="en-GB" smtClean="0"/>
-              <a:t>18/03/2026</a:t>
+              <a:t>20/03/2026</a:t>
             </a:fld>
             <a:endParaRPr lang="en-GB"/>
           </a:p>
@@ -6404,7 +6464,7 @@
           <a:p>
             <a:fld id="{E85DF616-B21E-4EF6-A6A5-95E2FB3EB1A1}" type="datetimeFigureOut">
               <a:rPr lang="en-GB" smtClean="0"/>
-              <a:t>18/03/2026</a:t>
+              <a:t>20/03/2026</a:t>
             </a:fld>
             <a:endParaRPr lang="en-GB"/>
           </a:p>
@@ -6604,7 +6664,7 @@
           <a:p>
             <a:fld id="{E85DF616-B21E-4EF6-A6A5-95E2FB3EB1A1}" type="datetimeFigureOut">
               <a:rPr lang="en-GB" smtClean="0"/>
-              <a:t>18/03/2026</a:t>
+              <a:t>20/03/2026</a:t>
             </a:fld>
             <a:endParaRPr lang="en-GB"/>
           </a:p>
@@ -6880,7 +6940,7 @@
           <a:p>
             <a:fld id="{E85DF616-B21E-4EF6-A6A5-95E2FB3EB1A1}" type="datetimeFigureOut">
               <a:rPr lang="en-GB" smtClean="0"/>
-              <a:t>18/03/2026</a:t>
+              <a:t>20/03/2026</a:t>
             </a:fld>
             <a:endParaRPr lang="en-GB"/>
           </a:p>
@@ -7148,7 +7208,7 @@
           <a:p>
             <a:fld id="{E85DF616-B21E-4EF6-A6A5-95E2FB3EB1A1}" type="datetimeFigureOut">
               <a:rPr lang="en-GB" smtClean="0"/>
-              <a:t>18/03/2026</a:t>
+              <a:t>20/03/2026</a:t>
             </a:fld>
             <a:endParaRPr lang="en-GB"/>
           </a:p>
@@ -7563,7 +7623,7 @@
           <a:p>
             <a:fld id="{E85DF616-B21E-4EF6-A6A5-95E2FB3EB1A1}" type="datetimeFigureOut">
               <a:rPr lang="en-GB" smtClean="0"/>
-              <a:t>18/03/2026</a:t>
+              <a:t>20/03/2026</a:t>
             </a:fld>
             <a:endParaRPr lang="en-GB"/>
           </a:p>
@@ -7705,7 +7765,7 @@
           <a:p>
             <a:fld id="{E85DF616-B21E-4EF6-A6A5-95E2FB3EB1A1}" type="datetimeFigureOut">
               <a:rPr lang="en-GB" smtClean="0"/>
-              <a:t>18/03/2026</a:t>
+              <a:t>20/03/2026</a:t>
             </a:fld>
             <a:endParaRPr lang="en-GB"/>
           </a:p>
@@ -7818,7 +7878,7 @@
           <a:p>
             <a:fld id="{E85DF616-B21E-4EF6-A6A5-95E2FB3EB1A1}" type="datetimeFigureOut">
               <a:rPr lang="en-GB" smtClean="0"/>
-              <a:t>18/03/2026</a:t>
+              <a:t>20/03/2026</a:t>
             </a:fld>
             <a:endParaRPr lang="en-GB"/>
           </a:p>
@@ -8131,7 +8191,7 @@
           <a:p>
             <a:fld id="{E85DF616-B21E-4EF6-A6A5-95E2FB3EB1A1}" type="datetimeFigureOut">
               <a:rPr lang="en-GB" smtClean="0"/>
-              <a:t>18/03/2026</a:t>
+              <a:t>20/03/2026</a:t>
             </a:fld>
             <a:endParaRPr lang="en-GB"/>
           </a:p>
@@ -8420,7 +8480,7 @@
           <a:p>
             <a:fld id="{E85DF616-B21E-4EF6-A6A5-95E2FB3EB1A1}" type="datetimeFigureOut">
               <a:rPr lang="en-GB" smtClean="0"/>
-              <a:t>18/03/2026</a:t>
+              <a:t>20/03/2026</a:t>
             </a:fld>
             <a:endParaRPr lang="en-GB"/>
           </a:p>
@@ -8663,7 +8723,7 @@
           <a:p>
             <a:fld id="{E85DF616-B21E-4EF6-A6A5-95E2FB3EB1A1}" type="datetimeFigureOut">
               <a:rPr lang="en-GB" smtClean="0"/>
-              <a:t>18/03/2026</a:t>
+              <a:t>20/03/2026</a:t>
             </a:fld>
             <a:endParaRPr lang="en-GB"/>
           </a:p>
@@ -15829,13 +15889,6 @@
               <a:t>After math is correct, have a look at how to implement it in a backward method (also shown in slides, but probably will be shown rapidly in class!)</a:t>
             </a:r>
           </a:p>
-          <a:p>
-            <a:r>
-              <a:rPr lang="en-GB" dirty="0"/>
-              <a:t>Remember, you have no homework this week, so let us call that your homework!</a:t>
-            </a:r>
-            <a:endParaRPr lang="en-SG" dirty="0"/>
-          </a:p>
         </p:txBody>
       </p:sp>
     </p:spTree>
@@ -15932,9 +15985,10 @@
           </a:p>
           <a:p>
             <a:r>
-              <a:rPr lang="en-US" dirty="0"/>
-              <a:t>Linear</a:t>
-            </a:r>
+              <a:rPr lang="en-US"/>
+              <a:t>Linear Regression</a:t>
+            </a:r>
+            <a:endParaRPr lang="en-US" dirty="0"/>
           </a:p>
           <a:p>
             <a:r>
@@ -19723,7 +19777,7 @@
               <a:blipFill>
                 <a:blip r:embed="rId2"/>
                 <a:stretch>
-                  <a:fillRect l="-1217" t="-1937" r="-986"/>
+                  <a:fillRect l="-1217" t="-1937" r="-986" b="-969"/>
                 </a:stretch>
               </a:blipFill>
             </p:spPr>
@@ -19827,7 +19881,7 @@
             </p:spPr>
             <p:txBody>
               <a:bodyPr>
-                <a:normAutofit/>
+                <a:normAutofit lnSpcReduction="10000"/>
               </a:bodyPr>
               <a:lstStyle/>
               <a:p>
@@ -21154,7 +21208,7 @@
               <a:blipFill>
                 <a:blip r:embed="rId2"/>
                 <a:stretch>
-                  <a:fillRect l="-1217" t="-1937" b="-1332"/>
+                  <a:fillRect l="-1217" t="-2663"/>
                 </a:stretch>
               </a:blipFill>
             </p:spPr>

</xml_diff>